<commit_message>
Mineures corrections ; correction du STOP par Diplomatie sur la piste de score
</commit_message>
<xml_diff>
--- a/pictures/Score-Track-fr/Design-Piste-Scores.pptx
+++ b/pictures/Score-Track-fr/Design-Piste-Scores.pptx
@@ -198,7 +198,7 @@
           <a:p>
             <a:fld id="{263B0988-6DB9-4E3D-B7FD-EFF3BCABE954}" type="datetimeFigureOut">
               <a:rPr lang="fr-FR" smtClean="0"/>
-              <a:t>06/04/2026</a:t>
+              <a:t>17/05/2026</a:t>
             </a:fld>
             <a:endParaRPr lang="fr-FR"/>
           </a:p>
@@ -696,7 +696,7 @@
           <a:p>
             <a:fld id="{588505E2-0C4C-443F-8F57-41958F504CA2}" type="datetimeFigureOut">
               <a:rPr lang="fr-FR" smtClean="0"/>
-              <a:t>06/04/2026</a:t>
+              <a:t>17/05/2026</a:t>
             </a:fld>
             <a:endParaRPr lang="fr-FR"/>
           </a:p>
@@ -894,7 +894,7 @@
           <a:p>
             <a:fld id="{588505E2-0C4C-443F-8F57-41958F504CA2}" type="datetimeFigureOut">
               <a:rPr lang="fr-FR" smtClean="0"/>
-              <a:t>06/04/2026</a:t>
+              <a:t>17/05/2026</a:t>
             </a:fld>
             <a:endParaRPr lang="fr-FR"/>
           </a:p>
@@ -1102,7 +1102,7 @@
           <a:p>
             <a:fld id="{588505E2-0C4C-443F-8F57-41958F504CA2}" type="datetimeFigureOut">
               <a:rPr lang="fr-FR" smtClean="0"/>
-              <a:t>06/04/2026</a:t>
+              <a:t>17/05/2026</a:t>
             </a:fld>
             <a:endParaRPr lang="fr-FR"/>
           </a:p>
@@ -1300,7 +1300,7 @@
           <a:p>
             <a:fld id="{588505E2-0C4C-443F-8F57-41958F504CA2}" type="datetimeFigureOut">
               <a:rPr lang="fr-FR" smtClean="0"/>
-              <a:t>06/04/2026</a:t>
+              <a:t>17/05/2026</a:t>
             </a:fld>
             <a:endParaRPr lang="fr-FR"/>
           </a:p>
@@ -1575,7 +1575,7 @@
           <a:p>
             <a:fld id="{588505E2-0C4C-443F-8F57-41958F504CA2}" type="datetimeFigureOut">
               <a:rPr lang="fr-FR" smtClean="0"/>
-              <a:t>06/04/2026</a:t>
+              <a:t>17/05/2026</a:t>
             </a:fld>
             <a:endParaRPr lang="fr-FR"/>
           </a:p>
@@ -1840,7 +1840,7 @@
           <a:p>
             <a:fld id="{588505E2-0C4C-443F-8F57-41958F504CA2}" type="datetimeFigureOut">
               <a:rPr lang="fr-FR" smtClean="0"/>
-              <a:t>06/04/2026</a:t>
+              <a:t>17/05/2026</a:t>
             </a:fld>
             <a:endParaRPr lang="fr-FR"/>
           </a:p>
@@ -2252,7 +2252,7 @@
           <a:p>
             <a:fld id="{588505E2-0C4C-443F-8F57-41958F504CA2}" type="datetimeFigureOut">
               <a:rPr lang="fr-FR" smtClean="0"/>
-              <a:t>06/04/2026</a:t>
+              <a:t>17/05/2026</a:t>
             </a:fld>
             <a:endParaRPr lang="fr-FR"/>
           </a:p>
@@ -2393,7 +2393,7 @@
           <a:p>
             <a:fld id="{588505E2-0C4C-443F-8F57-41958F504CA2}" type="datetimeFigureOut">
               <a:rPr lang="fr-FR" smtClean="0"/>
-              <a:t>06/04/2026</a:t>
+              <a:t>17/05/2026</a:t>
             </a:fld>
             <a:endParaRPr lang="fr-FR"/>
           </a:p>
@@ -2506,7 +2506,7 @@
           <a:p>
             <a:fld id="{588505E2-0C4C-443F-8F57-41958F504CA2}" type="datetimeFigureOut">
               <a:rPr lang="fr-FR" smtClean="0"/>
-              <a:t>06/04/2026</a:t>
+              <a:t>17/05/2026</a:t>
             </a:fld>
             <a:endParaRPr lang="fr-FR"/>
           </a:p>
@@ -2817,7 +2817,7 @@
           <a:p>
             <a:fld id="{588505E2-0C4C-443F-8F57-41958F504CA2}" type="datetimeFigureOut">
               <a:rPr lang="fr-FR" smtClean="0"/>
-              <a:t>06/04/2026</a:t>
+              <a:t>17/05/2026</a:t>
             </a:fld>
             <a:endParaRPr lang="fr-FR"/>
           </a:p>
@@ -3105,7 +3105,7 @@
           <a:p>
             <a:fld id="{588505E2-0C4C-443F-8F57-41958F504CA2}" type="datetimeFigureOut">
               <a:rPr lang="fr-FR" smtClean="0"/>
-              <a:t>06/04/2026</a:t>
+              <a:t>17/05/2026</a:t>
             </a:fld>
             <a:endParaRPr lang="fr-FR"/>
           </a:p>
@@ -3346,7 +3346,7 @@
           <a:p>
             <a:fld id="{588505E2-0C4C-443F-8F57-41958F504CA2}" type="datetimeFigureOut">
               <a:rPr lang="fr-FR" smtClean="0"/>
-              <a:t>06/04/2026</a:t>
+              <a:t>17/05/2026</a:t>
             </a:fld>
             <a:endParaRPr lang="fr-FR"/>
           </a:p>
@@ -7665,27 +7665,14 @@
             <a:p>
               <a:r>
                 <a:rPr lang="fr-FR" sz="1200" b="1" dirty="0">
-                  <a:latin typeface="Segoe UI" panose="020B0502040204020203" pitchFamily="34" charset="0"/>
-                  <a:cs typeface="Segoe UI" panose="020B0502040204020203" pitchFamily="34" charset="0"/>
-                </a:rPr>
-                <a:t>Fin de tour avec </a:t>
-              </a:r>
-              <a:r>
-                <a:rPr lang="fr-FR" sz="1200" b="1" dirty="0">
                   <a:solidFill>
                     <a:srgbClr val="FF0000"/>
                   </a:solidFill>
                   <a:latin typeface="Segoe UI" panose="020B0502040204020203" pitchFamily="34" charset="0"/>
                   <a:cs typeface="Segoe UI" panose="020B0502040204020203" pitchFamily="34" charset="0"/>
+                  <a:sym typeface="Wingdings" panose="05000000000000000000" pitchFamily="2" charset="2"/>
                 </a:rPr>
-                <a:t>5 calamités </a:t>
-              </a:r>
-              <a:r>
-                <a:rPr lang="fr-FR" sz="1200" b="1" dirty="0">
-                  <a:latin typeface="Segoe UI" panose="020B0502040204020203" pitchFamily="34" charset="0"/>
-                  <a:cs typeface="Segoe UI" panose="020B0502040204020203" pitchFamily="34" charset="0"/>
-                </a:rPr>
-                <a:t>ou plus </a:t>
+                <a:t>Hérauts réunis </a:t>
               </a:r>
               <a:r>
                 <a:rPr lang="fr-FR" sz="1200" b="1" dirty="0">
@@ -7693,7 +7680,7 @@
                   <a:cs typeface="Segoe UI" panose="020B0502040204020203" pitchFamily="34" charset="0"/>
                   <a:sym typeface="Wingdings" panose="05000000000000000000" pitchFamily="2" charset="2"/>
                 </a:rPr>
-                <a:t></a:t>
+                <a:t>au Conseil </a:t>
               </a:r>
               <a:r>
                 <a:rPr lang="fr-FR" sz="1200" b="1" dirty="0">

</xml_diff>